<commit_message>
Fix MCP tools hidden by on-demand loading; cover page overflow; sparse slides
- On-demand tool loading kept user-connected MCP tools out of the model's
  tool list, so they were never offered (desktop e2e: MCP call never
  reached the confirmation step). MCP tools now stay loaded when there
  are 12 or fewer of them
- Word cover: replace empty spacer paragraphs (which inherit 1.5x line
  spacing and paragraph spacing) with fixed spacing, so the cover fits
  on one page; the sample plan drops from 7 pages to 5
- PPT: 2-4 short points become numbered cards filling the slide;
  comparison boxes size to their content; wider bullet indent; taller
  rows for short tables
- Regenerated docs/samples and the single-file build

Verified: unit 503/503, smoke 126/127 (WebGL timing check only),
standalone 14/14, desktop 33/33; samples rendered with LibreOffice.

Co-Authored-By: Claude Opus 5.5 <noreply@anthropic.com>
Claude-Session: https://claude.ai/code/session_0165YW5YZypxDZBQXrf4B3xs
</commit_message>
<xml_diff>
--- a/docs/samples/经营汇报.pptx
+++ b/docs/samples/经营汇报.pptx
@@ -3013,7 +3013,7 @@
           </a:bodyPr>
           <a:lstStyle/>
           <a:p>
-            <a:pPr marL="228600" indent="-228600">
+            <a:pPr marL="330200" indent="-330200">
               <a:lnSpc>
                 <a:spcPct val="115000"/>
               </a:lnSpc>
@@ -3034,12 +3034,12 @@
             <a:endParaRPr lang="en-US" sz="2200" dirty="0"/>
           </a:p>
           <a:p>
-            <a:pPr marL="228600" indent="-228600">
+            <a:pPr marL="330200" indent="-330200">
               <a:lnSpc>
                 <a:spcPct val="115000"/>
               </a:lnSpc>
               <a:spcBef>
-                <a:spcPts val="800"/>
+                <a:spcPts val="1300"/>
               </a:spcBef>
               <a:buSzPct val="100000"/>
               <a:buChar char="■"/>
@@ -3058,12 +3058,12 @@
             <a:endParaRPr lang="en-US" sz="2200" dirty="0"/>
           </a:p>
           <a:p>
-            <a:pPr marL="228600" indent="-228600">
+            <a:pPr marL="330200" indent="-330200">
               <a:lnSpc>
                 <a:spcPct val="115000"/>
               </a:lnSpc>
               <a:spcBef>
-                <a:spcPts val="800"/>
+                <a:spcPts val="1300"/>
               </a:spcBef>
               <a:buSzPct val="100000"/>
               <a:buChar char="■"/>
@@ -3082,7 +3082,7 @@
             <a:endParaRPr lang="en-US" sz="2200" dirty="0"/>
           </a:p>
           <a:p>
-            <a:pPr lvl="1" marL="457200" indent="-228600">
+            <a:pPr lvl="1" marL="660400" indent="-330200">
               <a:lnSpc>
                 <a:spcPct val="115000"/>
               </a:lnSpc>
@@ -3435,7 +3435,7 @@
         <p:spPr>
           <a:xfrm>
             <a:off x="548640" y="2194560"/>
-            <a:ext cx="5410048" cy="4023360"/>
+            <a:ext cx="5410048" cy="1591056"/>
           </a:xfrm>
           <a:prstGeom prst="rect">
             <a:avLst/>
@@ -3446,15 +3446,15 @@
           <a:ln/>
         </p:spPr>
         <p:txBody>
-          <a:bodyPr wrap="square" lIns="152400" tIns="152400" rIns="152400" bIns="152400" rtlCol="0" anchor="t"/>
+          <a:bodyPr wrap="square" lIns="177800" tIns="177800" rIns="177800" bIns="177800" rtlCol="0" anchor="t"/>
           <a:lstStyle/>
           <a:p>
-            <a:pPr marL="228600" indent="-228600">
+            <a:pPr marL="330200" indent="-330200">
               <a:buSzPct val="100000"/>
               <a:buChar char="■"/>
             </a:pPr>
             <a:r>
-              <a:rPr lang="en-US" sz="1800" dirty="0">
+              <a:rPr lang="en-US" sz="2000" dirty="0">
                 <a:solidFill>
                   <a:srgbClr val="1F2328"/>
                 </a:solidFill>
@@ -3464,18 +3464,18 @@
               </a:rPr>
               <a:t>可控性强，客户关系留在公司</a:t>
             </a:r>
-            <a:endParaRPr lang="en-US" sz="1800" dirty="0"/>
-          </a:p>
-          <a:p>
-            <a:pPr marL="228600" indent="-228600">
+            <a:endParaRPr lang="en-US" sz="2000" dirty="0"/>
+          </a:p>
+          <a:p>
+            <a:pPr marL="330200" indent="-330200">
               <a:spcBef>
-                <a:spcPts val="800"/>
+                <a:spcPts val="1200"/>
               </a:spcBef>
               <a:buSzPct val="100000"/>
               <a:buChar char="■"/>
             </a:pPr>
             <a:r>
-              <a:rPr lang="en-US" sz="1800" dirty="0">
+              <a:rPr lang="en-US" sz="2000" dirty="0">
                 <a:solidFill>
                   <a:srgbClr val="1F2328"/>
                 </a:solidFill>
@@ -3485,7 +3485,7 @@
               </a:rPr>
               <a:t>人员成本每季度约 60 万元</a:t>
             </a:r>
-            <a:endParaRPr lang="en-US" sz="1800" dirty="0"/>
+            <a:endParaRPr lang="en-US" sz="2000" dirty="0"/>
           </a:p>
         </p:txBody>
       </p:sp>
@@ -3562,7 +3562,7 @@
         <p:spPr>
           <a:xfrm>
             <a:off x="6233008" y="2194560"/>
-            <a:ext cx="5410048" cy="4023360"/>
+            <a:ext cx="5410048" cy="1591056"/>
           </a:xfrm>
           <a:prstGeom prst="rect">
             <a:avLst/>
@@ -3573,15 +3573,15 @@
           <a:ln/>
         </p:spPr>
         <p:txBody>
-          <a:bodyPr wrap="square" lIns="152400" tIns="152400" rIns="152400" bIns="152400" rtlCol="0" anchor="t"/>
+          <a:bodyPr wrap="square" lIns="177800" tIns="177800" rIns="177800" bIns="177800" rtlCol="0" anchor="t"/>
           <a:lstStyle/>
           <a:p>
-            <a:pPr marL="228600" indent="-228600">
+            <a:pPr marL="330200" indent="-330200">
               <a:buSzPct val="100000"/>
               <a:buChar char="■"/>
             </a:pPr>
             <a:r>
-              <a:rPr lang="en-US" sz="1800" dirty="0">
+              <a:rPr lang="en-US" sz="2000" dirty="0">
                 <a:solidFill>
                   <a:srgbClr val="1F2328"/>
                 </a:solidFill>
@@ -3591,18 +3591,18 @@
               </a:rPr>
               <a:t>上线快，覆盖面广</a:t>
             </a:r>
-            <a:endParaRPr lang="en-US" sz="1800" dirty="0"/>
-          </a:p>
-          <a:p>
-            <a:pPr marL="228600" indent="-228600">
+            <a:endParaRPr lang="en-US" sz="2000" dirty="0"/>
+          </a:p>
+          <a:p>
+            <a:pPr marL="330200" indent="-330200">
               <a:spcBef>
-                <a:spcPts val="800"/>
+                <a:spcPts val="1200"/>
               </a:spcBef>
               <a:buSzPct val="100000"/>
               <a:buChar char="■"/>
             </a:pPr>
             <a:r>
-              <a:rPr lang="en-US" sz="1800" dirty="0">
+              <a:rPr lang="en-US" sz="2000" dirty="0">
                 <a:solidFill>
                   <a:srgbClr val="1F2328"/>
                 </a:solidFill>
@@ -3612,7 +3612,7 @@
               </a:rPr>
               <a:t>毛利让渡约 15%</a:t>
             </a:r>
-            <a:endParaRPr lang="en-US" sz="1800" dirty="0"/>
+            <a:endParaRPr lang="en-US" sz="2000" dirty="0"/>
           </a:p>
         </p:txBody>
       </p:sp>
@@ -3804,7 +3804,7 @@
                 <a:gridCol w="2773604"/>
                 <a:gridCol w="2773604"/>
               </a:tblGrid>
-              <a:tr h="0">
+              <a:tr h="566928">
                 <a:tc>
                   <a:txBody>
                     <a:bodyPr/>
@@ -3814,7 +3814,7 @@
                         <a:buNone/>
                       </a:pPr>
                       <a:r>
-                        <a:rPr lang="en-US" sz="1500" b="1" dirty="0">
+                        <a:rPr lang="en-US" sz="1600" b="1" dirty="0">
                           <a:solidFill>
                             <a:srgbClr val="FFFFFF"/>
                           </a:solidFill>
@@ -3824,7 +3824,7 @@
                         </a:rPr>
                         <a:t>工作事项</a:t>
                       </a:r>
-                      <a:endParaRPr lang="en-US" sz="1500" dirty="0">
+                      <a:endParaRPr lang="en-US" sz="1600" dirty="0">
                         <a:latin typeface="微软雅黑" charset="0"/>
                         <a:ea typeface="微软雅黑" charset="0"/>
                         <a:cs typeface="微软雅黑" charset="0"/>
@@ -3882,7 +3882,7 @@
                         <a:buNone/>
                       </a:pPr>
                       <a:r>
-                        <a:rPr lang="en-US" sz="1500" b="1" dirty="0">
+                        <a:rPr lang="en-US" sz="1600" b="1" dirty="0">
                           <a:solidFill>
                             <a:srgbClr val="FFFFFF"/>
                           </a:solidFill>
@@ -3892,7 +3892,7 @@
                         </a:rPr>
                         <a:t>目标</a:t>
                       </a:r>
-                      <a:endParaRPr lang="en-US" sz="1500" dirty="0">
+                      <a:endParaRPr lang="en-US" sz="1600" dirty="0">
                         <a:latin typeface="微软雅黑" charset="0"/>
                         <a:ea typeface="微软雅黑" charset="0"/>
                         <a:cs typeface="微软雅黑" charset="0"/>
@@ -3950,7 +3950,7 @@
                         <a:buNone/>
                       </a:pPr>
                       <a:r>
-                        <a:rPr lang="en-US" sz="1500" b="1" dirty="0">
+                        <a:rPr lang="en-US" sz="1600" b="1" dirty="0">
                           <a:solidFill>
                             <a:srgbClr val="FFFFFF"/>
                           </a:solidFill>
@@ -3960,7 +3960,7 @@
                         </a:rPr>
                         <a:t>负责人</a:t>
                       </a:r>
-                      <a:endParaRPr lang="en-US" sz="1500" dirty="0">
+                      <a:endParaRPr lang="en-US" sz="1600" dirty="0">
                         <a:latin typeface="微软雅黑" charset="0"/>
                         <a:ea typeface="微软雅黑" charset="0"/>
                         <a:cs typeface="微软雅黑" charset="0"/>
@@ -4018,7 +4018,7 @@
                         <a:buNone/>
                       </a:pPr>
                       <a:r>
-                        <a:rPr lang="en-US" sz="1500" b="1" dirty="0">
+                        <a:rPr lang="en-US" sz="1600" b="1" dirty="0">
                           <a:solidFill>
                             <a:srgbClr val="FFFFFF"/>
                           </a:solidFill>
@@ -4028,7 +4028,7 @@
                         </a:rPr>
                         <a:t>完成时间</a:t>
                       </a:r>
-                      <a:endParaRPr lang="en-US" sz="1500" dirty="0">
+                      <a:endParaRPr lang="en-US" sz="1600" dirty="0">
                         <a:latin typeface="微软雅黑" charset="0"/>
                         <a:ea typeface="微软雅黑" charset="0"/>
                         <a:cs typeface="微软雅黑" charset="0"/>
@@ -4078,7 +4078,7 @@
                   </a:tcPr>
                 </a:tc>
               </a:tr>
-              <a:tr h="0">
+              <a:tr h="566928">
                 <a:tc>
                   <a:txBody>
                     <a:bodyPr/>
@@ -4088,7 +4088,7 @@
                         <a:buNone/>
                       </a:pPr>
                       <a:r>
-                        <a:rPr lang="en-US" sz="1500" dirty="0">
+                        <a:rPr lang="en-US" sz="1600" dirty="0">
                           <a:solidFill>
                             <a:srgbClr val="1F2328"/>
                           </a:solidFill>
@@ -4098,7 +4098,7 @@
                         </a:rPr>
                         <a:t>回款专项清收</a:t>
                       </a:r>
-                      <a:endParaRPr lang="en-US" sz="1500" dirty="0">
+                      <a:endParaRPr lang="en-US" sz="1600" dirty="0">
                         <a:latin typeface="微软雅黑" charset="0"/>
                         <a:ea typeface="微软雅黑" charset="0"/>
                         <a:cs typeface="微软雅黑" charset="0"/>
@@ -4156,7 +4156,7 @@
                         <a:buNone/>
                       </a:pPr>
                       <a:r>
-                        <a:rPr lang="en-US" sz="1500" dirty="0">
+                        <a:rPr lang="en-US" sz="1600" dirty="0">
                           <a:solidFill>
                             <a:srgbClr val="1F2328"/>
                           </a:solidFill>
@@ -4170,7 +4170,7 @@
                         <a:buNone/>
                       </a:pPr>
                       <a:r>
-                        <a:rPr lang="en-US" sz="1500" dirty="0">
+                        <a:rPr lang="en-US" sz="1600" dirty="0">
                           <a:solidFill>
                             <a:srgbClr val="1F2328"/>
                           </a:solidFill>
@@ -4184,7 +4184,7 @@
                         <a:buNone/>
                       </a:pPr>
                       <a:r>
-                        <a:rPr lang="en-US" sz="1500" dirty="0">
+                        <a:rPr lang="en-US" sz="1600" dirty="0">
                           <a:solidFill>
                             <a:srgbClr val="1F2328"/>
                           </a:solidFill>
@@ -4194,7 +4194,7 @@
                         </a:rPr>
                         <a:t>天</a:t>
                       </a:r>
-                      <a:endParaRPr lang="en-US" sz="1500" dirty="0">
+                      <a:endParaRPr lang="en-US" sz="1600" dirty="0">
                         <a:latin typeface="微软雅黑" charset="0"/>
                         <a:ea typeface="微软雅黑" charset="0"/>
                         <a:cs typeface="微软雅黑" charset="0"/>
@@ -4252,7 +4252,7 @@
                         <a:buNone/>
                       </a:pPr>
                       <a:r>
-                        <a:rPr lang="en-US" sz="1500" dirty="0">
+                        <a:rPr lang="en-US" sz="1600" dirty="0">
                           <a:solidFill>
                             <a:srgbClr val="1F2328"/>
                           </a:solidFill>
@@ -4262,7 +4262,7 @@
                         </a:rPr>
                         <a:t>王敏</a:t>
                       </a:r>
-                      <a:endParaRPr lang="en-US" sz="1500" dirty="0">
+                      <a:endParaRPr lang="en-US" sz="1600" dirty="0">
                         <a:latin typeface="微软雅黑" charset="0"/>
                         <a:ea typeface="微软雅黑" charset="0"/>
                         <a:cs typeface="微软雅黑" charset="0"/>
@@ -4320,7 +4320,7 @@
                         <a:buNone/>
                       </a:pPr>
                       <a:r>
-                        <a:rPr lang="en-US" sz="1500" dirty="0">
+                        <a:rPr lang="en-US" sz="1600" dirty="0">
                           <a:solidFill>
                             <a:srgbClr val="1F2328"/>
                           </a:solidFill>
@@ -4334,7 +4334,7 @@
                         <a:buNone/>
                       </a:pPr>
                       <a:r>
-                        <a:rPr lang="en-US" sz="1500" dirty="0">
+                        <a:rPr lang="en-US" sz="1600" dirty="0">
                           <a:solidFill>
                             <a:srgbClr val="1F2328"/>
                           </a:solidFill>
@@ -4348,7 +4348,7 @@
                         <a:buNone/>
                       </a:pPr>
                       <a:r>
-                        <a:rPr lang="en-US" sz="1500" dirty="0">
+                        <a:rPr lang="en-US" sz="1600" dirty="0">
                           <a:solidFill>
                             <a:srgbClr val="1F2328"/>
                           </a:solidFill>
@@ -4362,7 +4362,7 @@
                         <a:buNone/>
                       </a:pPr>
                       <a:r>
-                        <a:rPr lang="en-US" sz="1500" dirty="0">
+                        <a:rPr lang="en-US" sz="1600" dirty="0">
                           <a:solidFill>
                             <a:srgbClr val="1F2328"/>
                           </a:solidFill>
@@ -4372,7 +4372,7 @@
                         </a:rPr>
                         <a:t>日</a:t>
                       </a:r>
-                      <a:endParaRPr lang="en-US" sz="1500" dirty="0">
+                      <a:endParaRPr lang="en-US" sz="1600" dirty="0">
                         <a:latin typeface="微软雅黑" charset="0"/>
                         <a:ea typeface="微软雅黑" charset="0"/>
                         <a:cs typeface="微软雅黑" charset="0"/>
@@ -4422,7 +4422,7 @@
                   </a:tcPr>
                 </a:tc>
               </a:tr>
-              <a:tr h="0">
+              <a:tr h="566928">
                 <a:tc>
                   <a:txBody>
                     <a:bodyPr/>
@@ -4432,7 +4432,7 @@
                         <a:buNone/>
                       </a:pPr>
                       <a:r>
-                        <a:rPr lang="en-US" sz="1500" dirty="0">
+                        <a:rPr lang="en-US" sz="1600" dirty="0">
                           <a:solidFill>
                             <a:srgbClr val="1F2328"/>
                           </a:solidFill>
@@ -4442,7 +4442,7 @@
                         </a:rPr>
                         <a:t>智能终端推广</a:t>
                       </a:r>
-                      <a:endParaRPr lang="en-US" sz="1500" dirty="0">
+                      <a:endParaRPr lang="en-US" sz="1600" dirty="0">
                         <a:latin typeface="微软雅黑" charset="0"/>
                         <a:ea typeface="微软雅黑" charset="0"/>
                         <a:cs typeface="微软雅黑" charset="0"/>
@@ -4500,7 +4500,7 @@
                         <a:buNone/>
                       </a:pPr>
                       <a:r>
-                        <a:rPr lang="en-US" sz="1500" dirty="0">
+                        <a:rPr lang="en-US" sz="1600" dirty="0">
                           <a:solidFill>
                             <a:srgbClr val="1F2328"/>
                           </a:solidFill>
@@ -4514,7 +4514,7 @@
                         <a:buNone/>
                       </a:pPr>
                       <a:r>
-                        <a:rPr lang="en-US" sz="1500" dirty="0">
+                        <a:rPr lang="en-US" sz="1600" dirty="0">
                           <a:solidFill>
                             <a:srgbClr val="1F2328"/>
                           </a:solidFill>
@@ -4528,7 +4528,7 @@
                         <a:buNone/>
                       </a:pPr>
                       <a:r>
-                        <a:rPr lang="en-US" sz="1500" dirty="0">
+                        <a:rPr lang="en-US" sz="1600" dirty="0">
                           <a:solidFill>
                             <a:srgbClr val="1F2328"/>
                           </a:solidFill>
@@ -4538,7 +4538,7 @@
                         </a:rPr>
                         <a:t>万元</a:t>
                       </a:r>
-                      <a:endParaRPr lang="en-US" sz="1500" dirty="0">
+                      <a:endParaRPr lang="en-US" sz="1600" dirty="0">
                         <a:latin typeface="微软雅黑" charset="0"/>
                         <a:ea typeface="微软雅黑" charset="0"/>
                         <a:cs typeface="微软雅黑" charset="0"/>
@@ -4596,7 +4596,7 @@
                         <a:buNone/>
                       </a:pPr>
                       <a:r>
-                        <a:rPr lang="en-US" sz="1500" dirty="0">
+                        <a:rPr lang="en-US" sz="1600" dirty="0">
                           <a:solidFill>
                             <a:srgbClr val="1F2328"/>
                           </a:solidFill>
@@ -4606,7 +4606,7 @@
                         </a:rPr>
                         <a:t>李强</a:t>
                       </a:r>
-                      <a:endParaRPr lang="en-US" sz="1500" dirty="0">
+                      <a:endParaRPr lang="en-US" sz="1600" dirty="0">
                         <a:latin typeface="微软雅黑" charset="0"/>
                         <a:ea typeface="微软雅黑" charset="0"/>
                         <a:cs typeface="微软雅黑" charset="0"/>
@@ -4664,7 +4664,7 @@
                         <a:buNone/>
                       </a:pPr>
                       <a:r>
-                        <a:rPr lang="en-US" sz="1500" dirty="0">
+                        <a:rPr lang="en-US" sz="1600" dirty="0">
                           <a:solidFill>
                             <a:srgbClr val="1F2328"/>
                           </a:solidFill>
@@ -4678,7 +4678,7 @@
                         <a:buNone/>
                       </a:pPr>
                       <a:r>
-                        <a:rPr lang="en-US" sz="1500" dirty="0">
+                        <a:rPr lang="en-US" sz="1600" dirty="0">
                           <a:solidFill>
                             <a:srgbClr val="1F2328"/>
                           </a:solidFill>
@@ -4692,7 +4692,7 @@
                         <a:buNone/>
                       </a:pPr>
                       <a:r>
-                        <a:rPr lang="en-US" sz="1500" dirty="0">
+                        <a:rPr lang="en-US" sz="1600" dirty="0">
                           <a:solidFill>
                             <a:srgbClr val="1F2328"/>
                           </a:solidFill>
@@ -4706,7 +4706,7 @@
                         <a:buNone/>
                       </a:pPr>
                       <a:r>
-                        <a:rPr lang="en-US" sz="1500" dirty="0">
+                        <a:rPr lang="en-US" sz="1600" dirty="0">
                           <a:solidFill>
                             <a:srgbClr val="1F2328"/>
                           </a:solidFill>
@@ -4716,7 +4716,7 @@
                         </a:rPr>
                         <a:t>日</a:t>
                       </a:r>
-                      <a:endParaRPr lang="en-US" sz="1500" dirty="0">
+                      <a:endParaRPr lang="en-US" sz="1600" dirty="0">
                         <a:latin typeface="微软雅黑" charset="0"/>
                         <a:ea typeface="微软雅黑" charset="0"/>
                         <a:cs typeface="微软雅黑" charset="0"/>

</xml_diff>